<commit_message>
Review phase 4: report pages
Latest-closed-month label on the bridge, gross margin defined once (collapsible),
target and break-even lines, quantified flags, runway reserves line, board
hierarchy and grant tones, accurate workings hint, embed-ready report shell.

Co-Authored-By: Claude Opus 5.5 <noreply@anthropic.com>
</commit_message>
<xml_diff>
--- a/media/exports/reports/2025-10/funding.pptx
+++ b/media/exports/reports/2025-10/funding.pptx
@@ -14,6 +14,7 @@
     <p:sldId id="262" r:id="rId13"/>
     <p:sldId id="263" r:id="rId14"/>
     <p:sldId id="264" r:id="rId15"/>
+    <p:sldId id="265" r:id="rId16"/>
   </p:sldIdLst>
   <p:sldSz cx="12191695" cy="6858000" type="screen4x3"/>
   <p:notesSz cx="6858000" cy="9144000"/>
@@ -4166,7 +4167,324 @@
                 </a:solidFill>
                 <a:latin typeface="Roboto"/>
               </a:rPr>
-              <a:t>Slide 1 of 9</a:t>
+              <a:t>Slide 1 of 10</a:t>
+            </a:r>
+          </a:p>
+        </p:txBody>
+      </p:sp>
+    </p:spTree>
+  </p:cSld>
+  <p:clrMapOvr>
+    <a:masterClrMapping/>
+  </p:clrMapOvr>
+</p:sld>
+</file>
+
+<file path=ppt/slides/slide10.xml><?xml version="1.0" encoding="utf-8"?>
+<p:sld xmlns:a="http://schemas.openxmlformats.org/drawingml/2006/main" xmlns:p="http://schemas.openxmlformats.org/presentationml/2006/main" xmlns:r="http://schemas.openxmlformats.org/officeDocument/2006/relationships">
+  <p:cSld>
+    <p:spTree>
+      <p:nvGrpSpPr>
+        <p:cNvPr id="1" name=""/>
+        <p:cNvGrpSpPr/>
+        <p:nvPr/>
+      </p:nvGrpSpPr>
+      <p:grpSpPr/>
+      <p:sp>
+        <p:nvSpPr>
+          <p:cNvPr id="2" name="Rectangle 1"/>
+          <p:cNvSpPr/>
+          <p:nvPr/>
+        </p:nvSpPr>
+        <p:spPr>
+          <a:xfrm>
+            <a:off x="0" y="0"/>
+            <a:ext cx="12191695" cy="73152"/>
+          </a:xfrm>
+          <a:prstGeom prst="rect">
+            <a:avLst/>
+          </a:prstGeom>
+          <a:solidFill>
+            <a:srgbClr val="2F7A5D"/>
+          </a:solidFill>
+          <a:ln>
+            <a:noFill/>
+          </a:ln>
+        </p:spPr>
+        <p:style>
+          <a:lnRef idx="1">
+            <a:schemeClr val="accent1"/>
+          </a:lnRef>
+          <a:fillRef idx="3">
+            <a:schemeClr val="accent1"/>
+          </a:fillRef>
+          <a:effectRef idx="2">
+            <a:schemeClr val="accent1"/>
+          </a:effectRef>
+          <a:fontRef idx="minor">
+            <a:schemeClr val="lt1"/>
+          </a:fontRef>
+        </p:style>
+        <p:txBody>
+          <a:bodyPr rtlCol="0" anchor="ctr"/>
+          <a:lstStyle/>
+          <a:p>
+            <a:pPr algn="ctr">
+              <a:defRPr>
+                <a:latin typeface="Roboto"/>
+              </a:defRPr>
+            </a:pPr>
+          </a:p>
+        </p:txBody>
+      </p:sp>
+      <p:sp>
+        <p:nvSpPr>
+          <p:cNvPr id="3" name="TextBox 2"/>
+          <p:cNvSpPr txBox="1"/>
+          <p:nvPr/>
+        </p:nvSpPr>
+        <p:spPr>
+          <a:xfrm>
+            <a:off x="457200" y="164592"/>
+            <a:ext cx="7315200" cy="274320"/>
+          </a:xfrm>
+          <a:prstGeom prst="rect">
+            <a:avLst/>
+          </a:prstGeom>
+          <a:noFill/>
+        </p:spPr>
+        <p:txBody>
+          <a:bodyPr wrap="square">
+            <a:spAutoFit/>
+          </a:bodyPr>
+          <a:lstStyle/>
+          <a:p>
+            <a:pPr>
+              <a:defRPr>
+                <a:latin typeface="Roboto"/>
+              </a:defRPr>
+            </a:pPr>
+            <a:r>
+              <a:rPr sz="1000" b="0">
+                <a:solidFill>
+                  <a:srgbClr val="5F6F63"/>
+                </a:solidFill>
+                <a:latin typeface="Roboto"/>
+              </a:rPr>
+              <a:t>Sample Community Services Ltd · Which funding is worth chasing?</a:t>
+            </a:r>
+          </a:p>
+        </p:txBody>
+      </p:sp>
+      <p:sp>
+        <p:nvSpPr>
+          <p:cNvPr id="4" name="TextBox 3"/>
+          <p:cNvSpPr txBox="1"/>
+          <p:nvPr/>
+        </p:nvSpPr>
+        <p:spPr>
+          <a:xfrm>
+            <a:off x="457200" y="411480"/>
+            <a:ext cx="11247120" cy="548640"/>
+          </a:xfrm>
+          <a:prstGeom prst="rect">
+            <a:avLst/>
+          </a:prstGeom>
+          <a:noFill/>
+        </p:spPr>
+        <p:txBody>
+          <a:bodyPr wrap="square">
+            <a:spAutoFit/>
+          </a:bodyPr>
+          <a:lstStyle/>
+          <a:p>
+            <a:pPr>
+              <a:defRPr>
+                <a:latin typeface="Roboto"/>
+              </a:defRPr>
+            </a:pPr>
+            <a:r>
+              <a:rPr sz="2400" b="1">
+                <a:solidFill>
+                  <a:srgbClr val="25342A"/>
+                </a:solidFill>
+                <a:latin typeface="Roboto"/>
+              </a:rPr>
+              <a:t>Raised and left after costs, by month · Left after costs $ · Every source at once</a:t>
+            </a:r>
+          </a:p>
+        </p:txBody>
+      </p:sp>
+      <p:sp>
+        <p:nvSpPr>
+          <p:cNvPr id="5" name="TextBox 4"/>
+          <p:cNvSpPr txBox="1"/>
+          <p:nvPr/>
+        </p:nvSpPr>
+        <p:spPr>
+          <a:xfrm>
+            <a:off x="457200" y="960120"/>
+            <a:ext cx="11247120" cy="457200"/>
+          </a:xfrm>
+          <a:prstGeom prst="rect">
+            <a:avLst/>
+          </a:prstGeom>
+          <a:noFill/>
+        </p:spPr>
+        <p:txBody>
+          <a:bodyPr wrap="square">
+            <a:spAutoFit/>
+          </a:bodyPr>
+          <a:lstStyle/>
+          <a:p>
+            <a:pPr>
+              <a:defRPr>
+                <a:latin typeface="Roboto"/>
+              </a:defRPr>
+            </a:pPr>
+            <a:r>
+              <a:rPr sz="1200" b="0">
+                <a:solidFill>
+                  <a:srgbClr val="5F6F63"/>
+                </a:solidFill>
+                <a:latin typeface="Roboto"/>
+              </a:rPr>
+              <a:t>Tap a month for its workings.</a:t>
+            </a:r>
+          </a:p>
+        </p:txBody>
+      </p:sp>
+      <p:graphicFrame>
+        <p:nvGraphicFramePr>
+          <p:cNvPr id="6" name="Chart 5"/>
+          <p:cNvGraphicFramePr>
+            <a:graphicFrameLocks noGrp="1"/>
+          </p:cNvGraphicFramePr>
+          <p:nvPr/>
+        </p:nvGraphicFramePr>
+        <p:xfrm>
+          <a:off x="457200" y="1463040"/>
+          <a:ext cx="11247120" cy="4754880"/>
+        </p:xfrm>
+        <a:graphic>
+          <a:graphicData uri="http://schemas.openxmlformats.org/drawingml/2006/chart">
+            <c:chart xmlns:c="http://schemas.openxmlformats.org/drawingml/2006/chart" r:id="rId2"/>
+          </a:graphicData>
+        </a:graphic>
+      </p:graphicFrame>
+      <p:sp>
+        <p:nvSpPr>
+          <p:cNvPr id="7" name="TextBox 6"/>
+          <p:cNvSpPr txBox="1"/>
+          <p:nvPr/>
+        </p:nvSpPr>
+        <p:spPr>
+          <a:xfrm>
+            <a:off x="457200" y="6492240"/>
+            <a:ext cx="3657600" cy="274320"/>
+          </a:xfrm>
+          <a:prstGeom prst="rect">
+            <a:avLst/>
+          </a:prstGeom>
+          <a:noFill/>
+        </p:spPr>
+        <p:txBody>
+          <a:bodyPr wrap="square">
+            <a:spAutoFit/>
+          </a:bodyPr>
+          <a:lstStyle/>
+          <a:p>
+            <a:pPr>
+              <a:defRPr>
+                <a:latin typeface="Roboto"/>
+              </a:defRPr>
+            </a:pPr>
+            <a:r>
+              <a:rPr sz="900" b="0">
+                <a:solidFill>
+                  <a:srgbClr val="5F6F63"/>
+                </a:solidFill>
+                <a:latin typeface="Roboto"/>
+              </a:rPr>
+              <a:t>funding.pptx</a:t>
+            </a:r>
+          </a:p>
+        </p:txBody>
+      </p:sp>
+      <p:sp>
+        <p:nvSpPr>
+          <p:cNvPr id="8" name="TextBox 7"/>
+          <p:cNvSpPr txBox="1"/>
+          <p:nvPr/>
+        </p:nvSpPr>
+        <p:spPr>
+          <a:xfrm>
+            <a:off x="4297680" y="6492240"/>
+            <a:ext cx="3657600" cy="274320"/>
+          </a:xfrm>
+          <a:prstGeom prst="rect">
+            <a:avLst/>
+          </a:prstGeom>
+          <a:noFill/>
+        </p:spPr>
+        <p:txBody>
+          <a:bodyPr wrap="square">
+            <a:spAutoFit/>
+          </a:bodyPr>
+          <a:lstStyle/>
+          <a:p>
+            <a:pPr algn="ctr">
+              <a:defRPr>
+                <a:latin typeface="Roboto"/>
+              </a:defRPr>
+            </a:pPr>
+            <a:r>
+              <a:rPr sz="900" b="0">
+                <a:solidFill>
+                  <a:srgbClr val="5F6F63"/>
+                </a:solidFill>
+                <a:latin typeface="Roboto"/>
+              </a:rPr>
+              <a:t>Data retrieved 2pm, Tue 6 Oct 2026 · Sample data</a:t>
+            </a:r>
+          </a:p>
+        </p:txBody>
+      </p:sp>
+      <p:sp>
+        <p:nvSpPr>
+          <p:cNvPr id="9" name="TextBox 8"/>
+          <p:cNvSpPr txBox="1"/>
+          <p:nvPr/>
+        </p:nvSpPr>
+        <p:spPr>
+          <a:xfrm>
+            <a:off x="8503920" y="6492240"/>
+            <a:ext cx="3200400" cy="274320"/>
+          </a:xfrm>
+          <a:prstGeom prst="rect">
+            <a:avLst/>
+          </a:prstGeom>
+          <a:noFill/>
+        </p:spPr>
+        <p:txBody>
+          <a:bodyPr wrap="square">
+            <a:spAutoFit/>
+          </a:bodyPr>
+          <a:lstStyle/>
+          <a:p>
+            <a:pPr algn="r">
+              <a:defRPr>
+                <a:latin typeface="Roboto"/>
+              </a:defRPr>
+            </a:pPr>
+            <a:r>
+              <a:rPr sz="900" b="0">
+                <a:solidFill>
+                  <a:srgbClr val="5F6F63"/>
+                </a:solidFill>
+                <a:latin typeface="Roboto"/>
+              </a:rPr>
+              <a:t>Slide 10 of 10</a:t>
             </a:r>
           </a:p>
         </p:txBody>
@@ -4444,7 +4762,7 @@
                 </a:solidFill>
                 <a:latin typeface="Roboto"/>
               </a:rPr>
-              <a:t>Slide 2 of 9</a:t>
+              <a:t>Slide 2 of 10</a:t>
             </a:r>
           </a:p>
         </p:txBody>
@@ -4958,7 +5276,7 @@
                 </a:solidFill>
                 <a:latin typeface="Roboto"/>
               </a:rPr>
-              <a:t>Slide 3 of 9</a:t>
+              <a:t>Slide 3 of 10</a:t>
             </a:r>
           </a:p>
         </p:txBody>
@@ -5472,7 +5790,7 @@
                 </a:solidFill>
                 <a:latin typeface="Roboto"/>
               </a:rPr>
-              <a:t>Slide 4 of 9</a:t>
+              <a:t>Slide 4 of 10</a:t>
             </a:r>
           </a:p>
         </p:txBody>
@@ -5986,7 +6304,7 @@
                 </a:solidFill>
                 <a:latin typeface="Roboto"/>
               </a:rPr>
-              <a:t>Slide 5 of 9</a:t>
+              <a:t>Slide 5 of 10</a:t>
             </a:r>
           </a:p>
         </p:txBody>
@@ -6500,7 +6818,7 @@
                 </a:solidFill>
                 <a:latin typeface="Roboto"/>
               </a:rPr>
-              <a:t>Slide 6 of 9</a:t>
+              <a:t>Slide 6 of 10</a:t>
             </a:r>
           </a:p>
         </p:txBody>
@@ -6514,6 +6832,764 @@
 </file>
 
 <file path=ppt/slides/slide7.xml><?xml version="1.0" encoding="utf-8"?>
+<p:sld xmlns:a="http://schemas.openxmlformats.org/drawingml/2006/main" xmlns:p="http://schemas.openxmlformats.org/presentationml/2006/main" xmlns:r="http://schemas.openxmlformats.org/officeDocument/2006/relationships">
+  <p:cSld>
+    <p:spTree>
+      <p:nvGrpSpPr>
+        <p:cNvPr id="1" name=""/>
+        <p:cNvGrpSpPr/>
+        <p:nvPr/>
+      </p:nvGrpSpPr>
+      <p:grpSpPr/>
+      <p:sp>
+        <p:nvSpPr>
+          <p:cNvPr id="2" name="Rectangle 1"/>
+          <p:cNvSpPr/>
+          <p:nvPr/>
+        </p:nvSpPr>
+        <p:spPr>
+          <a:xfrm>
+            <a:off x="0" y="0"/>
+            <a:ext cx="12191695" cy="73152"/>
+          </a:xfrm>
+          <a:prstGeom prst="rect">
+            <a:avLst/>
+          </a:prstGeom>
+          <a:solidFill>
+            <a:srgbClr val="2F7A5D"/>
+          </a:solidFill>
+          <a:ln>
+            <a:noFill/>
+          </a:ln>
+        </p:spPr>
+        <p:style>
+          <a:lnRef idx="1">
+            <a:schemeClr val="accent1"/>
+          </a:lnRef>
+          <a:fillRef idx="3">
+            <a:schemeClr val="accent1"/>
+          </a:fillRef>
+          <a:effectRef idx="2">
+            <a:schemeClr val="accent1"/>
+          </a:effectRef>
+          <a:fontRef idx="minor">
+            <a:schemeClr val="lt1"/>
+          </a:fontRef>
+        </p:style>
+        <p:txBody>
+          <a:bodyPr rtlCol="0" anchor="ctr"/>
+          <a:lstStyle/>
+          <a:p>
+            <a:pPr algn="ctr">
+              <a:defRPr>
+                <a:latin typeface="Roboto"/>
+              </a:defRPr>
+            </a:pPr>
+          </a:p>
+        </p:txBody>
+      </p:sp>
+      <p:sp>
+        <p:nvSpPr>
+          <p:cNvPr id="3" name="TextBox 2"/>
+          <p:cNvSpPr txBox="1"/>
+          <p:nvPr/>
+        </p:nvSpPr>
+        <p:spPr>
+          <a:xfrm>
+            <a:off x="457200" y="164592"/>
+            <a:ext cx="7315200" cy="274320"/>
+          </a:xfrm>
+          <a:prstGeom prst="rect">
+            <a:avLst/>
+          </a:prstGeom>
+          <a:noFill/>
+        </p:spPr>
+        <p:txBody>
+          <a:bodyPr wrap="square">
+            <a:spAutoFit/>
+          </a:bodyPr>
+          <a:lstStyle/>
+          <a:p>
+            <a:pPr>
+              <a:defRPr>
+                <a:latin typeface="Roboto"/>
+              </a:defRPr>
+            </a:pPr>
+            <a:r>
+              <a:rPr sz="1000" b="0">
+                <a:solidFill>
+                  <a:srgbClr val="5F6F63"/>
+                </a:solidFill>
+                <a:latin typeface="Roboto"/>
+              </a:rPr>
+              <a:t>Sample Community Services Ltd · Which funding is worth chasing?</a:t>
+            </a:r>
+          </a:p>
+        </p:txBody>
+      </p:sp>
+      <p:sp>
+        <p:nvSpPr>
+          <p:cNvPr id="4" name="TextBox 3"/>
+          <p:cNvSpPr txBox="1"/>
+          <p:nvPr/>
+        </p:nvSpPr>
+        <p:spPr>
+          <a:xfrm>
+            <a:off x="457200" y="411480"/>
+            <a:ext cx="11247120" cy="548640"/>
+          </a:xfrm>
+          <a:prstGeom prst="rect">
+            <a:avLst/>
+          </a:prstGeom>
+          <a:noFill/>
+        </p:spPr>
+        <p:txBody>
+          <a:bodyPr wrap="square">
+            <a:spAutoFit/>
+          </a:bodyPr>
+          <a:lstStyle/>
+          <a:p>
+            <a:pPr>
+              <a:defRPr>
+                <a:latin typeface="Roboto"/>
+              </a:defRPr>
+            </a:pPr>
+            <a:r>
+              <a:rPr sz="2400" b="1">
+                <a:solidFill>
+                  <a:srgbClr val="25342A"/>
+                </a:solidFill>
+                <a:latin typeface="Roboto"/>
+              </a:rPr>
+              <a:t>Headline numbers · Every source at once</a:t>
+            </a:r>
+          </a:p>
+        </p:txBody>
+      </p:sp>
+      <p:sp>
+        <p:nvSpPr>
+          <p:cNvPr id="5" name="Rectangle 4"/>
+          <p:cNvSpPr/>
+          <p:nvPr/>
+        </p:nvSpPr>
+        <p:spPr>
+          <a:xfrm>
+            <a:off x="457200" y="1645920"/>
+            <a:ext cx="3576218" cy="2011680"/>
+          </a:xfrm>
+          <a:prstGeom prst="rect">
+            <a:avLst/>
+          </a:prstGeom>
+          <a:solidFill>
+            <a:srgbClr val="F7FAF7"/>
+          </a:solidFill>
+          <a:ln>
+            <a:solidFill>
+              <a:srgbClr val="DCE8DC"/>
+            </a:solidFill>
+          </a:ln>
+        </p:spPr>
+        <p:style>
+          <a:lnRef idx="1">
+            <a:schemeClr val="accent1"/>
+          </a:lnRef>
+          <a:fillRef idx="3">
+            <a:schemeClr val="accent1"/>
+          </a:fillRef>
+          <a:effectRef idx="2">
+            <a:schemeClr val="accent1"/>
+          </a:effectRef>
+          <a:fontRef idx="minor">
+            <a:schemeClr val="lt1"/>
+          </a:fontRef>
+        </p:style>
+        <p:txBody>
+          <a:bodyPr rtlCol="0" anchor="ctr"/>
+          <a:lstStyle/>
+          <a:p>
+            <a:pPr algn="ctr">
+              <a:defRPr>
+                <a:latin typeface="Roboto"/>
+              </a:defRPr>
+            </a:pPr>
+          </a:p>
+        </p:txBody>
+      </p:sp>
+      <p:sp>
+        <p:nvSpPr>
+          <p:cNvPr id="6" name="TextBox 5"/>
+          <p:cNvSpPr txBox="1"/>
+          <p:nvPr/>
+        </p:nvSpPr>
+        <p:spPr>
+          <a:xfrm>
+            <a:off x="640080" y="1783080"/>
+            <a:ext cx="3210458" cy="457200"/>
+          </a:xfrm>
+          <a:prstGeom prst="rect">
+            <a:avLst/>
+          </a:prstGeom>
+          <a:noFill/>
+        </p:spPr>
+        <p:txBody>
+          <a:bodyPr wrap="square">
+            <a:spAutoFit/>
+          </a:bodyPr>
+          <a:lstStyle/>
+          <a:p>
+            <a:pPr>
+              <a:defRPr>
+                <a:latin typeface="Roboto"/>
+              </a:defRPr>
+            </a:pPr>
+            <a:r>
+              <a:rPr sz="1200" b="0">
+                <a:solidFill>
+                  <a:srgbClr val="5F6F63"/>
+                </a:solidFill>
+                <a:latin typeface="Roboto"/>
+              </a:rPr>
+              <a:t>Cheapest to raise: Grants</a:t>
+            </a:r>
+          </a:p>
+        </p:txBody>
+      </p:sp>
+      <p:sp>
+        <p:nvSpPr>
+          <p:cNvPr id="7" name="TextBox 6"/>
+          <p:cNvSpPr txBox="1"/>
+          <p:nvPr/>
+        </p:nvSpPr>
+        <p:spPr>
+          <a:xfrm>
+            <a:off x="640080" y="2240280"/>
+            <a:ext cx="3210458" cy="731520"/>
+          </a:xfrm>
+          <a:prstGeom prst="rect">
+            <a:avLst/>
+          </a:prstGeom>
+          <a:noFill/>
+        </p:spPr>
+        <p:txBody>
+          <a:bodyPr wrap="square">
+            <a:spAutoFit/>
+          </a:bodyPr>
+          <a:lstStyle/>
+          <a:p>
+            <a:pPr>
+              <a:defRPr>
+                <a:latin typeface="Roboto"/>
+              </a:defRPr>
+            </a:pPr>
+            <a:r>
+              <a:rPr sz="3000" b="1">
+                <a:solidFill>
+                  <a:srgbClr val="2F7A5D"/>
+                </a:solidFill>
+                <a:latin typeface="Roboto"/>
+              </a:rPr>
+              <a:t>10¢</a:t>
+            </a:r>
+          </a:p>
+        </p:txBody>
+      </p:sp>
+      <p:sp>
+        <p:nvSpPr>
+          <p:cNvPr id="8" name="TextBox 7"/>
+          <p:cNvSpPr txBox="1"/>
+          <p:nvPr/>
+        </p:nvSpPr>
+        <p:spPr>
+          <a:xfrm>
+            <a:off x="640080" y="3017520"/>
+            <a:ext cx="3210458" cy="548640"/>
+          </a:xfrm>
+          <a:prstGeom prst="rect">
+            <a:avLst/>
+          </a:prstGeom>
+          <a:noFill/>
+        </p:spPr>
+        <p:txBody>
+          <a:bodyPr wrap="square">
+            <a:spAutoFit/>
+          </a:bodyPr>
+          <a:lstStyle/>
+          <a:p>
+            <a:pPr>
+              <a:defRPr>
+                <a:latin typeface="Roboto"/>
+              </a:defRPr>
+            </a:pPr>
+            <a:r>
+              <a:rPr sz="1100" b="0">
+                <a:solidFill>
+                  <a:srgbClr val="5F6F63"/>
+                </a:solidFill>
+                <a:latin typeface="Roboto"/>
+              </a:rPr>
+              <a:t>per $1 raised in October</a:t>
+            </a:r>
+          </a:p>
+        </p:txBody>
+      </p:sp>
+      <p:sp>
+        <p:nvSpPr>
+          <p:cNvPr id="9" name="Rectangle 8"/>
+          <p:cNvSpPr/>
+          <p:nvPr/>
+        </p:nvSpPr>
+        <p:spPr>
+          <a:xfrm>
+            <a:off x="4307738" y="1645920"/>
+            <a:ext cx="3576218" cy="2011680"/>
+          </a:xfrm>
+          <a:prstGeom prst="rect">
+            <a:avLst/>
+          </a:prstGeom>
+          <a:solidFill>
+            <a:srgbClr val="F7FAF7"/>
+          </a:solidFill>
+          <a:ln>
+            <a:solidFill>
+              <a:srgbClr val="DCE8DC"/>
+            </a:solidFill>
+          </a:ln>
+        </p:spPr>
+        <p:style>
+          <a:lnRef idx="1">
+            <a:schemeClr val="accent1"/>
+          </a:lnRef>
+          <a:fillRef idx="3">
+            <a:schemeClr val="accent1"/>
+          </a:fillRef>
+          <a:effectRef idx="2">
+            <a:schemeClr val="accent1"/>
+          </a:effectRef>
+          <a:fontRef idx="minor">
+            <a:schemeClr val="lt1"/>
+          </a:fontRef>
+        </p:style>
+        <p:txBody>
+          <a:bodyPr rtlCol="0" anchor="ctr"/>
+          <a:lstStyle/>
+          <a:p>
+            <a:pPr algn="ctr">
+              <a:defRPr>
+                <a:latin typeface="Roboto"/>
+              </a:defRPr>
+            </a:pPr>
+          </a:p>
+        </p:txBody>
+      </p:sp>
+      <p:sp>
+        <p:nvSpPr>
+          <p:cNvPr id="10" name="TextBox 9"/>
+          <p:cNvSpPr txBox="1"/>
+          <p:nvPr/>
+        </p:nvSpPr>
+        <p:spPr>
+          <a:xfrm>
+            <a:off x="4490618" y="1783080"/>
+            <a:ext cx="3210458" cy="457200"/>
+          </a:xfrm>
+          <a:prstGeom prst="rect">
+            <a:avLst/>
+          </a:prstGeom>
+          <a:noFill/>
+        </p:spPr>
+        <p:txBody>
+          <a:bodyPr wrap="square">
+            <a:spAutoFit/>
+          </a:bodyPr>
+          <a:lstStyle/>
+          <a:p>
+            <a:pPr>
+              <a:defRPr>
+                <a:latin typeface="Roboto"/>
+              </a:defRPr>
+            </a:pPr>
+            <a:r>
+              <a:rPr sz="1200" b="0">
+                <a:solidFill>
+                  <a:srgbClr val="5F6F63"/>
+                </a:solidFill>
+                <a:latin typeface="Roboto"/>
+              </a:rPr>
+              <a:t>Dearest to raise: Donations</a:t>
+            </a:r>
+          </a:p>
+        </p:txBody>
+      </p:sp>
+      <p:sp>
+        <p:nvSpPr>
+          <p:cNvPr id="11" name="TextBox 10"/>
+          <p:cNvSpPr txBox="1"/>
+          <p:nvPr/>
+        </p:nvSpPr>
+        <p:spPr>
+          <a:xfrm>
+            <a:off x="4490618" y="2240280"/>
+            <a:ext cx="3210458" cy="731520"/>
+          </a:xfrm>
+          <a:prstGeom prst="rect">
+            <a:avLst/>
+          </a:prstGeom>
+          <a:noFill/>
+        </p:spPr>
+        <p:txBody>
+          <a:bodyPr wrap="square">
+            <a:spAutoFit/>
+          </a:bodyPr>
+          <a:lstStyle/>
+          <a:p>
+            <a:pPr>
+              <a:defRPr>
+                <a:latin typeface="Roboto"/>
+              </a:defRPr>
+            </a:pPr>
+            <a:r>
+              <a:rPr sz="3000" b="1">
+                <a:solidFill>
+                  <a:srgbClr val="2F7A5D"/>
+                </a:solidFill>
+                <a:latin typeface="Roboto"/>
+              </a:rPr>
+              <a:t>14¢</a:t>
+            </a:r>
+          </a:p>
+        </p:txBody>
+      </p:sp>
+      <p:sp>
+        <p:nvSpPr>
+          <p:cNvPr id="12" name="TextBox 11"/>
+          <p:cNvSpPr txBox="1"/>
+          <p:nvPr/>
+        </p:nvSpPr>
+        <p:spPr>
+          <a:xfrm>
+            <a:off x="4490618" y="3017520"/>
+            <a:ext cx="3210458" cy="548640"/>
+          </a:xfrm>
+          <a:prstGeom prst="rect">
+            <a:avLst/>
+          </a:prstGeom>
+          <a:noFill/>
+        </p:spPr>
+        <p:txBody>
+          <a:bodyPr wrap="square">
+            <a:spAutoFit/>
+          </a:bodyPr>
+          <a:lstStyle/>
+          <a:p>
+            <a:pPr>
+              <a:defRPr>
+                <a:latin typeface="Roboto"/>
+              </a:defRPr>
+            </a:pPr>
+            <a:r>
+              <a:rPr sz="1100" b="0">
+                <a:solidFill>
+                  <a:srgbClr val="5F6F63"/>
+                </a:solidFill>
+                <a:latin typeface="Roboto"/>
+              </a:rPr>
+              <a:t>per $1 raised in October</a:t>
+            </a:r>
+          </a:p>
+        </p:txBody>
+      </p:sp>
+      <p:sp>
+        <p:nvSpPr>
+          <p:cNvPr id="13" name="Rectangle 12"/>
+          <p:cNvSpPr/>
+          <p:nvPr/>
+        </p:nvSpPr>
+        <p:spPr>
+          <a:xfrm>
+            <a:off x="8158276" y="1645920"/>
+            <a:ext cx="3576218" cy="2011680"/>
+          </a:xfrm>
+          <a:prstGeom prst="rect">
+            <a:avLst/>
+          </a:prstGeom>
+          <a:solidFill>
+            <a:srgbClr val="F7FAF7"/>
+          </a:solidFill>
+          <a:ln>
+            <a:solidFill>
+              <a:srgbClr val="DCE8DC"/>
+            </a:solidFill>
+          </a:ln>
+        </p:spPr>
+        <p:style>
+          <a:lnRef idx="1">
+            <a:schemeClr val="accent1"/>
+          </a:lnRef>
+          <a:fillRef idx="3">
+            <a:schemeClr val="accent1"/>
+          </a:fillRef>
+          <a:effectRef idx="2">
+            <a:schemeClr val="accent1"/>
+          </a:effectRef>
+          <a:fontRef idx="minor">
+            <a:schemeClr val="lt1"/>
+          </a:fontRef>
+        </p:style>
+        <p:txBody>
+          <a:bodyPr rtlCol="0" anchor="ctr"/>
+          <a:lstStyle/>
+          <a:p>
+            <a:pPr algn="ctr">
+              <a:defRPr>
+                <a:latin typeface="Roboto"/>
+              </a:defRPr>
+            </a:pPr>
+          </a:p>
+        </p:txBody>
+      </p:sp>
+      <p:sp>
+        <p:nvSpPr>
+          <p:cNvPr id="14" name="TextBox 13"/>
+          <p:cNvSpPr txBox="1"/>
+          <p:nvPr/>
+        </p:nvSpPr>
+        <p:spPr>
+          <a:xfrm>
+            <a:off x="8341156" y="1783080"/>
+            <a:ext cx="3210458" cy="457200"/>
+          </a:xfrm>
+          <a:prstGeom prst="rect">
+            <a:avLst/>
+          </a:prstGeom>
+          <a:noFill/>
+        </p:spPr>
+        <p:txBody>
+          <a:bodyPr wrap="square">
+            <a:spAutoFit/>
+          </a:bodyPr>
+          <a:lstStyle/>
+          <a:p>
+            <a:pPr>
+              <a:defRPr>
+                <a:latin typeface="Roboto"/>
+              </a:defRPr>
+            </a:pPr>
+            <a:r>
+              <a:rPr sz="1200" b="0">
+                <a:solidFill>
+                  <a:srgbClr val="5F6F63"/>
+                </a:solidFill>
+                <a:latin typeface="Roboto"/>
+              </a:rPr>
+              <a:t>Raised, year to date</a:t>
+            </a:r>
+          </a:p>
+        </p:txBody>
+      </p:sp>
+      <p:sp>
+        <p:nvSpPr>
+          <p:cNvPr id="15" name="TextBox 14"/>
+          <p:cNvSpPr txBox="1"/>
+          <p:nvPr/>
+        </p:nvSpPr>
+        <p:spPr>
+          <a:xfrm>
+            <a:off x="8341156" y="2240280"/>
+            <a:ext cx="3210458" cy="731520"/>
+          </a:xfrm>
+          <a:prstGeom prst="rect">
+            <a:avLst/>
+          </a:prstGeom>
+          <a:noFill/>
+        </p:spPr>
+        <p:txBody>
+          <a:bodyPr wrap="square">
+            <a:spAutoFit/>
+          </a:bodyPr>
+          <a:lstStyle/>
+          <a:p>
+            <a:pPr>
+              <a:defRPr>
+                <a:latin typeface="Roboto"/>
+              </a:defRPr>
+            </a:pPr>
+            <a:r>
+              <a:rPr sz="3000" b="1">
+                <a:solidFill>
+                  <a:srgbClr val="2F7A5D"/>
+                </a:solidFill>
+                <a:latin typeface="Roboto"/>
+              </a:rPr>
+              <a:t>$350,529</a:t>
+            </a:r>
+          </a:p>
+        </p:txBody>
+      </p:sp>
+      <p:sp>
+        <p:nvSpPr>
+          <p:cNvPr id="16" name="TextBox 15"/>
+          <p:cNvSpPr txBox="1"/>
+          <p:nvPr/>
+        </p:nvSpPr>
+        <p:spPr>
+          <a:xfrm>
+            <a:off x="8341156" y="3017520"/>
+            <a:ext cx="3210458" cy="548640"/>
+          </a:xfrm>
+          <a:prstGeom prst="rect">
+            <a:avLst/>
+          </a:prstGeom>
+          <a:noFill/>
+        </p:spPr>
+        <p:txBody>
+          <a:bodyPr wrap="square">
+            <a:spAutoFit/>
+          </a:bodyPr>
+          <a:lstStyle/>
+          <a:p>
+            <a:pPr>
+              <a:defRPr>
+                <a:latin typeface="Roboto"/>
+              </a:defRPr>
+            </a:pPr>
+            <a:r>
+              <a:rPr sz="1100" b="0">
+                <a:solidFill>
+                  <a:srgbClr val="5F6F63"/>
+                </a:solidFill>
+                <a:latin typeface="Roboto"/>
+              </a:rPr>
+              <a:t>Jul to Oct 2025</a:t>
+            </a:r>
+          </a:p>
+        </p:txBody>
+      </p:sp>
+      <p:sp>
+        <p:nvSpPr>
+          <p:cNvPr id="17" name="TextBox 16"/>
+          <p:cNvSpPr txBox="1"/>
+          <p:nvPr/>
+        </p:nvSpPr>
+        <p:spPr>
+          <a:xfrm>
+            <a:off x="457200" y="6492240"/>
+            <a:ext cx="3657600" cy="274320"/>
+          </a:xfrm>
+          <a:prstGeom prst="rect">
+            <a:avLst/>
+          </a:prstGeom>
+          <a:noFill/>
+        </p:spPr>
+        <p:txBody>
+          <a:bodyPr wrap="square">
+            <a:spAutoFit/>
+          </a:bodyPr>
+          <a:lstStyle/>
+          <a:p>
+            <a:pPr>
+              <a:defRPr>
+                <a:latin typeface="Roboto"/>
+              </a:defRPr>
+            </a:pPr>
+            <a:r>
+              <a:rPr sz="900" b="0">
+                <a:solidFill>
+                  <a:srgbClr val="5F6F63"/>
+                </a:solidFill>
+                <a:latin typeface="Roboto"/>
+              </a:rPr>
+              <a:t>funding.pptx</a:t>
+            </a:r>
+          </a:p>
+        </p:txBody>
+      </p:sp>
+      <p:sp>
+        <p:nvSpPr>
+          <p:cNvPr id="18" name="TextBox 17"/>
+          <p:cNvSpPr txBox="1"/>
+          <p:nvPr/>
+        </p:nvSpPr>
+        <p:spPr>
+          <a:xfrm>
+            <a:off x="4297680" y="6492240"/>
+            <a:ext cx="3657600" cy="274320"/>
+          </a:xfrm>
+          <a:prstGeom prst="rect">
+            <a:avLst/>
+          </a:prstGeom>
+          <a:noFill/>
+        </p:spPr>
+        <p:txBody>
+          <a:bodyPr wrap="square">
+            <a:spAutoFit/>
+          </a:bodyPr>
+          <a:lstStyle/>
+          <a:p>
+            <a:pPr algn="ctr">
+              <a:defRPr>
+                <a:latin typeface="Roboto"/>
+              </a:defRPr>
+            </a:pPr>
+            <a:r>
+              <a:rPr sz="900" b="0">
+                <a:solidFill>
+                  <a:srgbClr val="5F6F63"/>
+                </a:solidFill>
+                <a:latin typeface="Roboto"/>
+              </a:rPr>
+              <a:t>Data retrieved 2pm, Tue 6 Oct 2026 · Sample data</a:t>
+            </a:r>
+          </a:p>
+        </p:txBody>
+      </p:sp>
+      <p:sp>
+        <p:nvSpPr>
+          <p:cNvPr id="19" name="TextBox 18"/>
+          <p:cNvSpPr txBox="1"/>
+          <p:nvPr/>
+        </p:nvSpPr>
+        <p:spPr>
+          <a:xfrm>
+            <a:off x="8503920" y="6492240"/>
+            <a:ext cx="3200400" cy="274320"/>
+          </a:xfrm>
+          <a:prstGeom prst="rect">
+            <a:avLst/>
+          </a:prstGeom>
+          <a:noFill/>
+        </p:spPr>
+        <p:txBody>
+          <a:bodyPr wrap="square">
+            <a:spAutoFit/>
+          </a:bodyPr>
+          <a:lstStyle/>
+          <a:p>
+            <a:pPr algn="r">
+              <a:defRPr>
+                <a:latin typeface="Roboto"/>
+              </a:defRPr>
+            </a:pPr>
+            <a:r>
+              <a:rPr sz="900" b="0">
+                <a:solidFill>
+                  <a:srgbClr val="5F6F63"/>
+                </a:solidFill>
+                <a:latin typeface="Roboto"/>
+              </a:rPr>
+              <a:t>Slide 7 of 10</a:t>
+            </a:r>
+          </a:p>
+        </p:txBody>
+      </p:sp>
+    </p:spTree>
+  </p:cSld>
+  <p:clrMapOvr>
+    <a:masterClrMapping/>
+  </p:clrMapOvr>
+</p:sld>
+</file>
+
+<file path=ppt/slides/slide8.xml><?xml version="1.0" encoding="utf-8"?>
 <p:sld xmlns:a="http://schemas.openxmlformats.org/drawingml/2006/main" xmlns:p="http://schemas.openxmlformats.org/presentationml/2006/main" xmlns:r="http://schemas.openxmlformats.org/officeDocument/2006/relationships">
   <p:cSld>
     <p:spTree>
@@ -7328,324 +8404,7 @@
                 </a:solidFill>
                 <a:latin typeface="Roboto"/>
               </a:rPr>
-              <a:t>Slide 7 of 9</a:t>
-            </a:r>
-          </a:p>
-        </p:txBody>
-      </p:sp>
-    </p:spTree>
-  </p:cSld>
-  <p:clrMapOvr>
-    <a:masterClrMapping/>
-  </p:clrMapOvr>
-</p:sld>
-</file>
-
-<file path=ppt/slides/slide8.xml><?xml version="1.0" encoding="utf-8"?>
-<p:sld xmlns:a="http://schemas.openxmlformats.org/drawingml/2006/main" xmlns:p="http://schemas.openxmlformats.org/presentationml/2006/main" xmlns:r="http://schemas.openxmlformats.org/officeDocument/2006/relationships">
-  <p:cSld>
-    <p:spTree>
-      <p:nvGrpSpPr>
-        <p:cNvPr id="1" name=""/>
-        <p:cNvGrpSpPr/>
-        <p:nvPr/>
-      </p:nvGrpSpPr>
-      <p:grpSpPr/>
-      <p:sp>
-        <p:nvSpPr>
-          <p:cNvPr id="2" name="Rectangle 1"/>
-          <p:cNvSpPr/>
-          <p:nvPr/>
-        </p:nvSpPr>
-        <p:spPr>
-          <a:xfrm>
-            <a:off x="0" y="0"/>
-            <a:ext cx="12191695" cy="73152"/>
-          </a:xfrm>
-          <a:prstGeom prst="rect">
-            <a:avLst/>
-          </a:prstGeom>
-          <a:solidFill>
-            <a:srgbClr val="2F7A5D"/>
-          </a:solidFill>
-          <a:ln>
-            <a:noFill/>
-          </a:ln>
-        </p:spPr>
-        <p:style>
-          <a:lnRef idx="1">
-            <a:schemeClr val="accent1"/>
-          </a:lnRef>
-          <a:fillRef idx="3">
-            <a:schemeClr val="accent1"/>
-          </a:fillRef>
-          <a:effectRef idx="2">
-            <a:schemeClr val="accent1"/>
-          </a:effectRef>
-          <a:fontRef idx="minor">
-            <a:schemeClr val="lt1"/>
-          </a:fontRef>
-        </p:style>
-        <p:txBody>
-          <a:bodyPr rtlCol="0" anchor="ctr"/>
-          <a:lstStyle/>
-          <a:p>
-            <a:pPr algn="ctr">
-              <a:defRPr>
-                <a:latin typeface="Roboto"/>
-              </a:defRPr>
-            </a:pPr>
-          </a:p>
-        </p:txBody>
-      </p:sp>
-      <p:sp>
-        <p:nvSpPr>
-          <p:cNvPr id="3" name="TextBox 2"/>
-          <p:cNvSpPr txBox="1"/>
-          <p:nvPr/>
-        </p:nvSpPr>
-        <p:spPr>
-          <a:xfrm>
-            <a:off x="457200" y="164592"/>
-            <a:ext cx="7315200" cy="274320"/>
-          </a:xfrm>
-          <a:prstGeom prst="rect">
-            <a:avLst/>
-          </a:prstGeom>
-          <a:noFill/>
-        </p:spPr>
-        <p:txBody>
-          <a:bodyPr wrap="square">
-            <a:spAutoFit/>
-          </a:bodyPr>
-          <a:lstStyle/>
-          <a:p>
-            <a:pPr>
-              <a:defRPr>
-                <a:latin typeface="Roboto"/>
-              </a:defRPr>
-            </a:pPr>
-            <a:r>
-              <a:rPr sz="1000" b="0">
-                <a:solidFill>
-                  <a:srgbClr val="5F6F63"/>
-                </a:solidFill>
-                <a:latin typeface="Roboto"/>
-              </a:rPr>
-              <a:t>Sample Community Services Ltd · Which funding is worth chasing?</a:t>
-            </a:r>
-          </a:p>
-        </p:txBody>
-      </p:sp>
-      <p:sp>
-        <p:nvSpPr>
-          <p:cNvPr id="4" name="TextBox 3"/>
-          <p:cNvSpPr txBox="1"/>
-          <p:nvPr/>
-        </p:nvSpPr>
-        <p:spPr>
-          <a:xfrm>
-            <a:off x="457200" y="411480"/>
-            <a:ext cx="11247120" cy="548640"/>
-          </a:xfrm>
-          <a:prstGeom prst="rect">
-            <a:avLst/>
-          </a:prstGeom>
-          <a:noFill/>
-        </p:spPr>
-        <p:txBody>
-          <a:bodyPr wrap="square">
-            <a:spAutoFit/>
-          </a:bodyPr>
-          <a:lstStyle/>
-          <a:p>
-            <a:pPr>
-              <a:defRPr>
-                <a:latin typeface="Roboto"/>
-              </a:defRPr>
-            </a:pPr>
-            <a:r>
-              <a:rPr sz="2400" b="1">
-                <a:solidFill>
-                  <a:srgbClr val="25342A"/>
-                </a:solidFill>
-                <a:latin typeface="Roboto"/>
-              </a:rPr>
-              <a:t>Raised and left after costs, by month · Raised $ · Every source at once</a:t>
-            </a:r>
-          </a:p>
-        </p:txBody>
-      </p:sp>
-      <p:sp>
-        <p:nvSpPr>
-          <p:cNvPr id="5" name="TextBox 4"/>
-          <p:cNvSpPr txBox="1"/>
-          <p:nvPr/>
-        </p:nvSpPr>
-        <p:spPr>
-          <a:xfrm>
-            <a:off x="457200" y="960120"/>
-            <a:ext cx="11247120" cy="457200"/>
-          </a:xfrm>
-          <a:prstGeom prst="rect">
-            <a:avLst/>
-          </a:prstGeom>
-          <a:noFill/>
-        </p:spPr>
-        <p:txBody>
-          <a:bodyPr wrap="square">
-            <a:spAutoFit/>
-          </a:bodyPr>
-          <a:lstStyle/>
-          <a:p>
-            <a:pPr>
-              <a:defRPr>
-                <a:latin typeface="Roboto"/>
-              </a:defRPr>
-            </a:pPr>
-            <a:r>
-              <a:rPr sz="1200" b="0">
-                <a:solidFill>
-                  <a:srgbClr val="5F6F63"/>
-                </a:solidFill>
-                <a:latin typeface="Roboto"/>
-              </a:rPr>
-              <a:t>Tap a month for its workings.</a:t>
-            </a:r>
-          </a:p>
-        </p:txBody>
-      </p:sp>
-      <p:graphicFrame>
-        <p:nvGraphicFramePr>
-          <p:cNvPr id="6" name="Chart 5"/>
-          <p:cNvGraphicFramePr>
-            <a:graphicFrameLocks noGrp="1"/>
-          </p:cNvGraphicFramePr>
-          <p:nvPr/>
-        </p:nvGraphicFramePr>
-        <p:xfrm>
-          <a:off x="457200" y="1463040"/>
-          <a:ext cx="11247120" cy="4754880"/>
-        </p:xfrm>
-        <a:graphic>
-          <a:graphicData uri="http://schemas.openxmlformats.org/drawingml/2006/chart">
-            <c:chart xmlns:c="http://schemas.openxmlformats.org/drawingml/2006/chart" r:id="rId2"/>
-          </a:graphicData>
-        </a:graphic>
-      </p:graphicFrame>
-      <p:sp>
-        <p:nvSpPr>
-          <p:cNvPr id="7" name="TextBox 6"/>
-          <p:cNvSpPr txBox="1"/>
-          <p:nvPr/>
-        </p:nvSpPr>
-        <p:spPr>
-          <a:xfrm>
-            <a:off x="457200" y="6492240"/>
-            <a:ext cx="3657600" cy="274320"/>
-          </a:xfrm>
-          <a:prstGeom prst="rect">
-            <a:avLst/>
-          </a:prstGeom>
-          <a:noFill/>
-        </p:spPr>
-        <p:txBody>
-          <a:bodyPr wrap="square">
-            <a:spAutoFit/>
-          </a:bodyPr>
-          <a:lstStyle/>
-          <a:p>
-            <a:pPr>
-              <a:defRPr>
-                <a:latin typeface="Roboto"/>
-              </a:defRPr>
-            </a:pPr>
-            <a:r>
-              <a:rPr sz="900" b="0">
-                <a:solidFill>
-                  <a:srgbClr val="5F6F63"/>
-                </a:solidFill>
-                <a:latin typeface="Roboto"/>
-              </a:rPr>
-              <a:t>funding.pptx</a:t>
-            </a:r>
-          </a:p>
-        </p:txBody>
-      </p:sp>
-      <p:sp>
-        <p:nvSpPr>
-          <p:cNvPr id="8" name="TextBox 7"/>
-          <p:cNvSpPr txBox="1"/>
-          <p:nvPr/>
-        </p:nvSpPr>
-        <p:spPr>
-          <a:xfrm>
-            <a:off x="4297680" y="6492240"/>
-            <a:ext cx="3657600" cy="274320"/>
-          </a:xfrm>
-          <a:prstGeom prst="rect">
-            <a:avLst/>
-          </a:prstGeom>
-          <a:noFill/>
-        </p:spPr>
-        <p:txBody>
-          <a:bodyPr wrap="square">
-            <a:spAutoFit/>
-          </a:bodyPr>
-          <a:lstStyle/>
-          <a:p>
-            <a:pPr algn="ctr">
-              <a:defRPr>
-                <a:latin typeface="Roboto"/>
-              </a:defRPr>
-            </a:pPr>
-            <a:r>
-              <a:rPr sz="900" b="0">
-                <a:solidFill>
-                  <a:srgbClr val="5F6F63"/>
-                </a:solidFill>
-                <a:latin typeface="Roboto"/>
-              </a:rPr>
-              <a:t>Data retrieved 2pm, Tue 6 Oct 2026 · Sample data</a:t>
-            </a:r>
-          </a:p>
-        </p:txBody>
-      </p:sp>
-      <p:sp>
-        <p:nvSpPr>
-          <p:cNvPr id="9" name="TextBox 8"/>
-          <p:cNvSpPr txBox="1"/>
-          <p:nvPr/>
-        </p:nvSpPr>
-        <p:spPr>
-          <a:xfrm>
-            <a:off x="8503920" y="6492240"/>
-            <a:ext cx="3200400" cy="274320"/>
-          </a:xfrm>
-          <a:prstGeom prst="rect">
-            <a:avLst/>
-          </a:prstGeom>
-          <a:noFill/>
-        </p:spPr>
-        <p:txBody>
-          <a:bodyPr wrap="square">
-            <a:spAutoFit/>
-          </a:bodyPr>
-          <a:lstStyle/>
-          <a:p>
-            <a:pPr algn="r">
-              <a:defRPr>
-                <a:latin typeface="Roboto"/>
-              </a:defRPr>
-            </a:pPr>
-            <a:r>
-              <a:rPr sz="900" b="0">
-                <a:solidFill>
-                  <a:srgbClr val="5F6F63"/>
-                </a:solidFill>
-                <a:latin typeface="Roboto"/>
-              </a:rPr>
-              <a:t>Slide 8 of 9</a:t>
+              <a:t>Slide 8 of 10</a:t>
             </a:r>
           </a:p>
         </p:txBody>
@@ -7788,7 +8547,7 @@
                 </a:solidFill>
                 <a:latin typeface="Roboto"/>
               </a:rPr>
-              <a:t>Raised and left after costs, by month · Left after costs $ · Every source at once</a:t>
+              <a:t>Raised and left after costs, by month · Raised $ · Every source at once</a:t>
             </a:r>
           </a:p>
         </p:txBody>
@@ -7962,7 +8721,7 @@
                 </a:solidFill>
                 <a:latin typeface="Roboto"/>
               </a:rPr>
-              <a:t>Slide 9 of 9</a:t>
+              <a:t>Slide 9 of 10</a:t>
             </a:r>
           </a:p>
         </p:txBody>

</xml_diff>